<commit_message>
TI.1.3: completar diagramas y documentación
</commit_message>
<xml_diff>
--- a/P1/TI.1.3. PAO202651_RESTFUL_JAVA_SINBDD_NRC_36883_GR07/05. DOCUMENTACION/PRESENTACION/PRESENTACION TI.1.3 RESTful Java sin BDD GR07.pptx
+++ b/P1/TI.1.3. PAO202651_RESTFUL_JAVA_SINBDD_NRC_36883_GR07/05. DOCUMENTACION/PRESENTACION/PRESENTACION TI.1.3 RESTful Java sin BDD GR07.pptx
@@ -33530,30 +33530,30 @@
 </file>
 
 <file path=ppt/slides/slide80.xml><?xml version="1.0" encoding="utf-8"?>
-<p:sld xmlns:a="http://schemas.openxmlformats.org/drawingml/2006/main" xmlns:p="http://schemas.openxmlformats.org/presentationml/2006/main" xmlns:r="http://schemas.openxmlformats.org/officeDocument/2006/relationships">
-  <p:cSld>
-    <p:bg>
-      <p:bgPr>
+<ns0:sld xmlns:a="http://schemas.openxmlformats.org/drawingml/2006/main" xmlns:ns0="http://schemas.openxmlformats.org/presentationml/2006/main">
+  <ns0:cSld>
+    <ns0:bg>
+      <ns0:bgPr>
         <a:solidFill>
           <a:srgbClr val="FFFFFF"/>
         </a:solidFill>
         <a:effectLst/>
-      </p:bgPr>
-    </p:bg>
-    <p:spTree>
-      <p:nvGrpSpPr>
-        <p:cNvPr id="1" name=""/>
-        <p:cNvGrpSpPr/>
-        <p:nvPr/>
-      </p:nvGrpSpPr>
-      <p:grpSpPr/>
-      <p:sp>
-        <p:nvSpPr>
-          <p:cNvPr id="2" name="Rectangle 1"/>
-          <p:cNvSpPr/>
-          <p:nvPr/>
-        </p:nvSpPr>
-        <p:spPr>
+      </ns0:bgPr>
+    </ns0:bg>
+    <ns0:spTree>
+      <ns0:nvGrpSpPr>
+        <ns0:cNvPr id="1" name=""/>
+        <ns0:cNvGrpSpPr/>
+        <ns0:nvPr/>
+      </ns0:nvGrpSpPr>
+      <ns0:grpSpPr/>
+      <ns0:sp>
+        <ns0:nvSpPr>
+          <ns0:cNvPr id="2" name="Rectangle 1"/>
+          <ns0:cNvSpPr/>
+          <ns0:nvPr/>
+        </ns0:nvSpPr>
+        <ns0:spPr>
           <a:xfrm>
             <a:off x="0" y="0"/>
             <a:ext cx="201168" cy="10287000"/>
@@ -33567,8 +33567,8 @@
           <a:ln>
             <a:noFill/>
           </a:ln>
-        </p:spPr>
-        <p:style>
+        </ns0:spPr>
+        <ns0:style>
           <a:lnRef idx="1">
             <a:schemeClr val="accent1"/>
           </a:lnRef>
@@ -33581,22 +33581,22 @@
           <a:fontRef idx="minor">
             <a:schemeClr val="lt1"/>
           </a:fontRef>
-        </p:style>
-        <p:txBody>
+        </ns0:style>
+        <ns0:txBody>
           <a:bodyPr rtlCol="0" anchor="ctr"/>
           <a:lstStyle/>
           <a:p>
             <a:pPr algn="ctr"/>
           </a:p>
-        </p:txBody>
-      </p:sp>
-      <p:sp>
-        <p:nvSpPr>
-          <p:cNvPr id="3" name="Rectangle 2"/>
-          <p:cNvSpPr/>
-          <p:nvPr/>
-        </p:nvSpPr>
-        <p:spPr>
+        </ns0:txBody>
+      </ns0:sp>
+      <ns0:sp>
+        <ns0:nvSpPr>
+          <ns0:cNvPr id="3" name="Rectangle 2"/>
+          <ns0:cNvSpPr/>
+          <ns0:nvPr/>
+        </ns0:nvSpPr>
+        <ns0:spPr>
           <a:xfrm>
             <a:off x="201168" y="0"/>
             <a:ext cx="18086832" cy="146304"/>
@@ -33610,8 +33610,8 @@
           <a:ln>
             <a:noFill/>
           </a:ln>
-        </p:spPr>
-        <p:style>
+        </ns0:spPr>
+        <ns0:style>
           <a:lnRef idx="1">
             <a:schemeClr val="accent1"/>
           </a:lnRef>
@@ -33624,22 +33624,22 @@
           <a:fontRef idx="minor">
             <a:schemeClr val="lt1"/>
           </a:fontRef>
-        </p:style>
-        <p:txBody>
+        </ns0:style>
+        <ns0:txBody>
           <a:bodyPr rtlCol="0" anchor="ctr"/>
           <a:lstStyle/>
           <a:p>
             <a:pPr algn="ctr"/>
           </a:p>
-        </p:txBody>
-      </p:sp>
-      <p:sp>
-        <p:nvSpPr>
-          <p:cNvPr id="4" name="TextBox 3"/>
-          <p:cNvSpPr txBox="1"/>
-          <p:nvPr/>
-        </p:nvSpPr>
-        <p:spPr>
+        </ns0:txBody>
+      </ns0:sp>
+      <ns0:sp>
+        <ns0:nvSpPr>
+          <ns0:cNvPr id="4" name="TextBox 3"/>
+          <ns0:cNvSpPr txBox="1"/>
+          <ns0:nvPr/>
+        </ns0:nvSpPr>
+        <ns0:spPr>
           <a:xfrm>
             <a:off x="731520" y="384048"/>
             <a:ext cx="15910559" cy="685800"/>
@@ -33648,8 +33648,8 @@
             <a:avLst/>
           </a:prstGeom>
           <a:noFill/>
-        </p:spPr>
-        <p:txBody>
+        </ns0:spPr>
+        <ns0:txBody>
           <a:bodyPr wrap="square" lIns="73152" rIns="73152">
             <a:normAutofit/>
           </a:bodyPr>
@@ -33663,18 +33663,18 @@
                 </a:solidFill>
                 <a:latin typeface="Arial"/>
               </a:rPr>
-              <a:t>Trabajo pendiente de diagramas</a:t>
-            </a:r>
-          </a:p>
-        </p:txBody>
-      </p:sp>
-      <p:sp>
-        <p:nvSpPr>
-          <p:cNvPr id="5" name="TextBox 4"/>
-          <p:cNvSpPr txBox="1"/>
-          <p:nvPr/>
-        </p:nvSpPr>
-        <p:spPr>
+              <a:t>Diagramas UML de TI.1.3</a:t>
+            </a:r>
+          </a:p>
+        </ns0:txBody>
+      </ns0:sp>
+      <ns0:sp>
+        <ns0:nvSpPr>
+          <ns0:cNvPr id="5" name="TextBox 4"/>
+          <ns0:cNvSpPr txBox="1"/>
+          <ns0:nvPr/>
+        </ns0:nvSpPr>
+        <ns0:spPr>
           <a:xfrm>
             <a:off x="16550640" y="475488"/>
             <a:ext cx="914400" cy="320040"/>
@@ -33683,8 +33683,8 @@
             <a:avLst/>
           </a:prstGeom>
           <a:noFill/>
-        </p:spPr>
-        <p:txBody>
+        </ns0:spPr>
+        <ns0:txBody>
           <a:bodyPr wrap="square" lIns="73152" rIns="73152">
             <a:normAutofit/>
           </a:bodyPr>
@@ -33701,15 +33701,15 @@
               <a:t>80</a:t>
             </a:r>
           </a:p>
-        </p:txBody>
-      </p:sp>
-      <p:sp>
-        <p:nvSpPr>
-          <p:cNvPr id="6" name="Rounded Rectangle 5"/>
-          <p:cNvSpPr/>
-          <p:nvPr/>
-        </p:nvSpPr>
-        <p:spPr>
+        </ns0:txBody>
+      </ns0:sp>
+      <ns0:sp>
+        <ns0:nvSpPr>
+          <ns0:cNvPr id="6" name="Rounded Rectangle 5"/>
+          <ns0:cNvSpPr/>
+          <ns0:nvPr/>
+        </ns0:nvSpPr>
+        <ns0:spPr>
           <a:xfrm>
             <a:off x="731520" y="1417320"/>
             <a:ext cx="16916400" cy="8092440"/>
@@ -33725,8 +33725,8 @@
               <a:srgbClr val="CFDCF0"/>
             </a:solidFill>
           </a:ln>
-        </p:spPr>
-        <p:style>
+        </ns0:spPr>
+        <ns0:style>
           <a:lnRef idx="1">
             <a:schemeClr val="accent1"/>
           </a:lnRef>
@@ -33739,8 +33739,8 @@
           <a:fontRef idx="minor">
             <a:schemeClr val="lt1"/>
           </a:fontRef>
-        </p:style>
-        <p:txBody>
+        </ns0:style>
+        <ns0:txBody>
           <a:bodyPr rtlCol="0" anchor="ctr" wrap="square" lIns="411480" rIns="365760" tIns="320040" bIns="228600">
             <a:normAutofit/>
           </a:bodyPr>
@@ -33758,7 +33758,7 @@
               </a:defRPr>
             </a:pPr>
             <a:r>
-              <a:t>•  Los modelos .oom y exportaciones deben generarse en PowerDesigner.</a:t>
+              <a:t>•  Elaborados en PowerDesigner: cinco modelos .oom y cinco PNG.</a:t>
             </a:r>
           </a:p>
           <a:p>
@@ -33774,7 +33774,7 @@
               </a:defRPr>
             </a:pPr>
             <a:r>
-              <a:t>•  PowerDesigner no está disponible en este equipo.</a:t>
+              <a:t>•  Casos de uso, actividad, secuencia, clases y arquitectura.</a:t>
             </a:r>
           </a:p>
           <a:p>
@@ -33790,18 +33790,18 @@
               </a:defRPr>
             </a:pPr>
             <a:r>
-              <a:t>•  No se sustituyeron por diagramas generados ni PlantUML.</a:t>
-            </a:r>
-          </a:p>
-        </p:txBody>
-      </p:sp>
-      <p:sp>
-        <p:nvSpPr>
-          <p:cNvPr id="7" name="Rectangle 6"/>
-          <p:cNvSpPr/>
-          <p:nvPr/>
-        </p:nvSpPr>
-        <p:spPr>
+              <a:t>•  Modelos editables: 01. UML/03. DIAGRAMAS.</a:t>
+            </a:r>
+          </a:p>
+        </ns0:txBody>
+      </ns0:sp>
+      <ns0:sp>
+        <ns0:nvSpPr>
+          <ns0:cNvPr id="7" name="Rectangle 6"/>
+          <ns0:cNvSpPr/>
+          <ns0:nvPr/>
+        </ns0:nvSpPr>
+        <ns0:spPr>
           <a:xfrm>
             <a:off x="731520" y="9738360"/>
             <a:ext cx="16916400" cy="13716"/>
@@ -33815,8 +33815,8 @@
           <a:ln>
             <a:noFill/>
           </a:ln>
-        </p:spPr>
-        <p:style>
+        </ns0:spPr>
+        <ns0:style>
           <a:lnRef idx="1">
             <a:schemeClr val="accent1"/>
           </a:lnRef>
@@ -33829,22 +33829,22 @@
           <a:fontRef idx="minor">
             <a:schemeClr val="lt1"/>
           </a:fontRef>
-        </p:style>
-        <p:txBody>
+        </ns0:style>
+        <ns0:txBody>
           <a:bodyPr rtlCol="0" anchor="ctr"/>
           <a:lstStyle/>
           <a:p>
             <a:pPr algn="ctr"/>
           </a:p>
-        </p:txBody>
-      </p:sp>
-      <p:sp>
-        <p:nvSpPr>
-          <p:cNvPr id="8" name="TextBox 7"/>
-          <p:cNvSpPr txBox="1"/>
-          <p:nvPr/>
-        </p:nvSpPr>
-        <p:spPr>
+        </ns0:txBody>
+      </ns0:sp>
+      <ns0:sp>
+        <ns0:nvSpPr>
+          <ns0:cNvPr id="8" name="TextBox 7"/>
+          <ns0:cNvSpPr txBox="1"/>
+          <ns0:nvPr/>
+        </ns0:nvSpPr>
+        <ns0:spPr>
           <a:xfrm>
             <a:off x="822960" y="9802368"/>
             <a:ext cx="16002000" cy="292608"/>
@@ -33853,8 +33853,8 @@
             <a:avLst/>
           </a:prstGeom>
           <a:noFill/>
-        </p:spPr>
-        <p:txBody>
+        </ns0:spPr>
+        <ns0:txBody>
           <a:bodyPr wrap="square" lIns="73152" rIns="73152">
             <a:normAutofit/>
           </a:bodyPr>
@@ -33871,15 +33871,15 @@
               <a:t>TI.1.3 · RESTful Java sin BDD · Grupo 7</a:t>
             </a:r>
           </a:p>
-        </p:txBody>
-      </p:sp>
-      <p:sp>
-        <p:nvSpPr>
-          <p:cNvPr id="9" name="TextBox 8"/>
-          <p:cNvSpPr txBox="1"/>
-          <p:nvPr/>
-        </p:nvSpPr>
-        <p:spPr>
+        </ns0:txBody>
+      </ns0:sp>
+      <ns0:sp>
+        <ns0:nvSpPr>
+          <ns0:cNvPr id="9" name="TextBox 8"/>
+          <ns0:cNvSpPr txBox="1"/>
+          <ns0:nvPr/>
+        </ns0:nvSpPr>
+        <ns0:spPr>
           <a:xfrm>
             <a:off x="16459200" y="9802368"/>
             <a:ext cx="1005840" cy="292608"/>
@@ -33888,8 +33888,8 @@
             <a:avLst/>
           </a:prstGeom>
           <a:noFill/>
-        </p:spPr>
-        <p:txBody>
+        </ns0:spPr>
+        <ns0:txBody>
           <a:bodyPr wrap="square" lIns="73152" rIns="73152">
             <a:normAutofit/>
           </a:bodyPr>
@@ -33906,14 +33906,14 @@
               <a:t>80/81</a:t>
             </a:r>
           </a:p>
-        </p:txBody>
-      </p:sp>
-    </p:spTree>
-  </p:cSld>
-  <p:clrMapOvr>
+        </ns0:txBody>
+      </ns0:sp>
+    </ns0:spTree>
+  </ns0:cSld>
+  <ns0:clrMapOvr>
     <a:masterClrMapping/>
-  </p:clrMapOvr>
-</p:sld>
+  </ns0:clrMapOvr>
+</ns0:sld>
 </file>
 
 <file path=ppt/slides/slide81.xml><?xml version="1.0" encoding="utf-8"?>

</xml_diff>